<commit_message>
Fix pre-launch chart, alignment and brand issues (#18)
Bar charts keep negative value labels clear of category labels (fixed plot area and label room); long line-chart end labels wrap between name and value; exhibit+takeaways text starts level with the exhibit (new deck-build/deck-review agreement test); theme, color and font schemes are named "SoWhat Decks" with a repo-wide test. Examples 01-03 rebuilt (only exhibit+takeaways slides changed), review counts, READMEs and README images updated. Closes #14, #15, #16, #17.

Co-Authored-By: Claude Opus 5.5 <noreply@anthropic.com>
</commit_message>
<xml_diff>
--- a/examples/01-investor-update/deck.pptx
+++ b/examples/01-investor-update/deck.pptx
@@ -125,6 +125,17 @@
   <c:chart>
     <c:autoTitleDeleted val="1"/>
     <c:plotArea>
+      <c:layout>
+        <c:manualLayout>
+          <c:layoutTarget val="inner"/>
+          <c:xMode val="edge"/>
+          <c:yMode val="edge"/>
+          <c:x val="0.0200"/>
+          <c:y val="0.0400"/>
+          <c:w val="0.9600"/>
+          <c:h val="0.8940"/>
+        </c:manualLayout>
+      </c:layout>
       <c:barChart>
         <c:barDir val="col"/>
         <c:grouping val="clustered"/>
@@ -289,7 +300,7 @@
       <c:valAx>
         <c:axId val="-2113994440"/>
         <c:scaling>
-          <c:max val="1162.112"/>
+          <c:max val="1104.610355594492"/>
           <c:min val="0.0"/>
         </c:scaling>
         <c:delete/>
@@ -378,9 +389,10 @@
               <c:idx val="2"/>
               <c:tx>
                 <c:rich>
-                  <a:bodyPr/>
+                  <a:bodyPr wrap="none"/>
                   <a:lstStyle/>
                   <a:p>
+                    <a:pPr algn="l"/>
                     <a:r>
                       <a:rPr sz="1200" b="0">
                         <a:solidFill>
@@ -471,9 +483,10 @@
               <c:idx val="2"/>
               <c:tx>
                 <c:rich>
-                  <a:bodyPr/>
+                  <a:bodyPr wrap="none"/>
                   <a:lstStyle/>
                   <a:p>
+                    <a:pPr algn="l"/>
                     <a:r>
                       <a:rPr sz="1200" b="1">
                         <a:solidFill>
@@ -954,9 +967,10 @@
               <c:idx val="1"/>
               <c:tx>
                 <c:rich>
-                  <a:bodyPr/>
+                  <a:bodyPr wrap="none"/>
                   <a:lstStyle/>
                   <a:p>
+                    <a:pPr algn="l"/>
                     <a:r>
                       <a:rPr sz="1200" b="1">
                         <a:solidFill>
@@ -1050,9 +1064,10 @@
               </c:layout>
               <c:tx>
                 <c:rich>
-                  <a:bodyPr/>
+                  <a:bodyPr wrap="none"/>
                   <a:lstStyle/>
                   <a:p>
+                    <a:pPr algn="l"/>
                     <a:r>
                       <a:rPr sz="1200" b="0">
                         <a:solidFill>
@@ -1140,9 +1155,10 @@
               <c:idx val="1"/>
               <c:tx>
                 <c:rich>
-                  <a:bodyPr/>
+                  <a:bodyPr wrap="none"/>
                   <a:lstStyle/>
                   <a:p>
+                    <a:pPr algn="l"/>
                     <a:r>
                       <a:rPr sz="1200" b="0">
                         <a:solidFill>
@@ -1323,6 +1339,17 @@
   <c:chart>
     <c:autoTitleDeleted val="1"/>
     <c:plotArea>
+      <c:layout>
+        <c:manualLayout>
+          <c:layoutTarget val="inner"/>
+          <c:xMode val="edge"/>
+          <c:yMode val="edge"/>
+          <c:x val="0.0200"/>
+          <c:y val="0.0400"/>
+          <c:w val="0.9600"/>
+          <c:h val="0.8940"/>
+        </c:manualLayout>
+      </c:layout>
       <c:barChart>
         <c:barDir val="col"/>
         <c:grouping val="clustered"/>
@@ -1481,7 +1508,7 @@
       <c:valAx>
         <c:axId val="-2113994440"/>
         <c:scaling>
-          <c:max val="44.352000000000004"/>
+          <c:max val="42.15744996293551"/>
           <c:min val="0.0"/>
         </c:scaling>
         <c:delete/>
@@ -1527,6 +1554,17 @@
   <c:chart>
     <c:autoTitleDeleted val="1"/>
     <c:plotArea>
+      <c:layout>
+        <c:manualLayout>
+          <c:layoutTarget val="inner"/>
+          <c:xMode val="edge"/>
+          <c:yMode val="edge"/>
+          <c:x val="0.0200"/>
+          <c:y val="0.0400"/>
+          <c:w val="0.9600"/>
+          <c:h val="0.8940"/>
+        </c:manualLayout>
+      </c:layout>
       <c:barChart>
         <c:barDir val="col"/>
         <c:grouping val="clustered"/>
@@ -1685,7 +1723,7 @@
       <c:valAx>
         <c:axId val="-2113994440"/>
         <c:scaling>
-          <c:max val="13.664"/>
+          <c:max val="12.987901251207404"/>
           <c:min val="0.0"/>
         </c:scaling>
         <c:delete/>
@@ -1731,6 +1769,17 @@
   <c:chart>
     <c:autoTitleDeleted val="1"/>
     <c:plotArea>
+      <c:layout>
+        <c:manualLayout>
+          <c:layoutTarget val="inner"/>
+          <c:xMode val="edge"/>
+          <c:yMode val="edge"/>
+          <c:x val="0.0200"/>
+          <c:y val="0.0400"/>
+          <c:w val="0.9600"/>
+          <c:h val="0.8916"/>
+        </c:manualLayout>
+      </c:layout>
       <c:barChart>
         <c:barDir val="col"/>
         <c:grouping val="clustered"/>
@@ -1895,7 +1944,7 @@
       <c:valAx>
         <c:axId val="-2113994440"/>
         <c:scaling>
-          <c:max val="44.800000000000004"/>
+          <c:max val="42.692136620081"/>
           <c:min val="0.0"/>
         </c:scaling>
         <c:delete/>
@@ -1941,6 +1990,17 @@
   <c:chart>
     <c:autoTitleDeleted val="1"/>
     <c:plotArea>
+      <c:layout>
+        <c:manualLayout>
+          <c:layoutTarget val="inner"/>
+          <c:xMode val="edge"/>
+          <c:yMode val="edge"/>
+          <c:x val="0.0200"/>
+          <c:y val="0.0400"/>
+          <c:w val="0.9600"/>
+          <c:h val="0.8916"/>
+        </c:manualLayout>
+      </c:layout>
       <c:barChart>
         <c:barDir val="col"/>
         <c:grouping val="clustered"/>
@@ -2150,7 +2210,7 @@
       <c:valAx>
         <c:axId val="-2113994440"/>
         <c:scaling>
-          <c:max val="81.98400000000001"/>
+          <c:max val="78.12661001474822"/>
           <c:min val="0.0"/>
         </c:scaling>
         <c:delete/>
@@ -2196,6 +2256,17 @@
   <c:chart>
     <c:autoTitleDeleted val="1"/>
     <c:plotArea>
+      <c:layout>
+        <c:manualLayout>
+          <c:layoutTarget val="inner"/>
+          <c:xMode val="edge"/>
+          <c:yMode val="edge"/>
+          <c:x val="0.2203"/>
+          <c:y val="0.0200"/>
+          <c:w val="0.7697"/>
+          <c:h val="0.9600"/>
+        </c:manualLayout>
+      </c:layout>
       <c:barChart>
         <c:barDir val="bar"/>
         <c:grouping val="clustered"/>
@@ -2360,7 +2431,7 @@
       <c:valAx>
         <c:axId val="-2113994440"/>
         <c:scaling>
-          <c:max val="1222.952"/>
+          <c:max val="1128.6105321230584"/>
           <c:min val="0.0"/>
         </c:scaling>
         <c:delete/>
@@ -5305,8 +5376,8 @@
         </p:nvSpPr>
         <p:spPr>
           <a:xfrm>
-            <a:off x="8097520" y="2014220"/>
-            <a:ext cx="3637280" cy="4102100"/>
+            <a:off x="8097520" y="1959864"/>
+            <a:ext cx="3637280" cy="4156456"/>
           </a:xfrm>
           <a:prstGeom prst="rect">
             <a:avLst/>
@@ -5668,8 +5739,8 @@
         </p:nvSpPr>
         <p:spPr>
           <a:xfrm>
-            <a:off x="8097520" y="2014220"/>
-            <a:ext cx="3637280" cy="4254500"/>
+            <a:off x="8097520" y="1959864"/>
+            <a:ext cx="3637280" cy="4308856"/>
           </a:xfrm>
           <a:prstGeom prst="rect">
             <a:avLst/>
@@ -9446,8 +9517,8 @@
         </p:nvSpPr>
         <p:spPr>
           <a:xfrm>
-            <a:off x="8097520" y="2014220"/>
-            <a:ext cx="3637280" cy="4254500"/>
+            <a:off x="8097520" y="1959864"/>
+            <a:ext cx="3637280" cy="4308856"/>
           </a:xfrm>
           <a:prstGeom prst="rect">
             <a:avLst/>
@@ -9789,8 +9860,8 @@
         </p:nvSpPr>
         <p:spPr>
           <a:xfrm>
-            <a:off x="8097520" y="2014220"/>
-            <a:ext cx="3637280" cy="4254500"/>
+            <a:off x="8097520" y="1959864"/>
+            <a:ext cx="3637280" cy="4308856"/>
           </a:xfrm>
           <a:prstGeom prst="rect">
             <a:avLst/>
@@ -10258,8 +10329,8 @@
         </p:nvSpPr>
         <p:spPr>
           <a:xfrm>
-            <a:off x="8097520" y="2014220"/>
-            <a:ext cx="3637280" cy="4254500"/>
+            <a:off x="8097520" y="1959864"/>
+            <a:ext cx="3637280" cy="4308856"/>
           </a:xfrm>
           <a:prstGeom prst="rect">
             <a:avLst/>
@@ -10621,8 +10692,8 @@
         </p:nvSpPr>
         <p:spPr>
           <a:xfrm>
-            <a:off x="8097520" y="2014220"/>
-            <a:ext cx="3637280" cy="4254500"/>
+            <a:off x="8097520" y="1959864"/>
+            <a:ext cx="3637280" cy="4308856"/>
           </a:xfrm>
           <a:prstGeom prst="rect">
             <a:avLst/>
@@ -10984,8 +11055,8 @@
         </p:nvSpPr>
         <p:spPr>
           <a:xfrm>
-            <a:off x="8097520" y="2014220"/>
-            <a:ext cx="3637280" cy="4254500"/>
+            <a:off x="8097520" y="1959864"/>
+            <a:ext cx="3637280" cy="4308856"/>
           </a:xfrm>
           <a:prstGeom prst="rect">
             <a:avLst/>
@@ -11327,8 +11398,8 @@
         </p:nvSpPr>
         <p:spPr>
           <a:xfrm>
-            <a:off x="8097520" y="2014220"/>
-            <a:ext cx="3637280" cy="4254500"/>
+            <a:off x="8097520" y="1959864"/>
+            <a:ext cx="3637280" cy="4308856"/>
           </a:xfrm>
           <a:prstGeom prst="rect">
             <a:avLst/>
@@ -11689,8 +11760,8 @@
         </p:nvSpPr>
         <p:spPr>
           <a:xfrm>
-            <a:off x="8097520" y="2014220"/>
-            <a:ext cx="3637280" cy="4102100"/>
+            <a:off x="8097520" y="1959864"/>
+            <a:ext cx="3637280" cy="4156456"/>
           </a:xfrm>
           <a:prstGeom prst="rect">
             <a:avLst/>
@@ -11773,9 +11844,9 @@
 </file>
 
 <file path=ppt/theme/theme1.xml><?xml version="1.0" encoding="utf-8"?>
-<a:theme xmlns:a="http://schemas.openxmlformats.org/drawingml/2006/main" name="SoWhat">
+<a:theme xmlns:a="http://schemas.openxmlformats.org/drawingml/2006/main" name="SoWhat Decks">
   <a:themeElements>
-    <a:clrScheme name="SoWhat">
+    <a:clrScheme name="SoWhat Decks">
       <a:dk1>
         <a:srgbClr val="1E2329"/>
       </a:dk1>
@@ -11813,7 +11884,7 @@
         <a:srgbClr val="5A6472"/>
       </a:folHlink>
     </a:clrScheme>
-    <a:fontScheme name="SoWhat">
+    <a:fontScheme name="SoWhat Decks">
       <a:majorFont>
         <a:latin typeface="Georgia"/>
         <a:ea typeface=""/>

</xml_diff>